<commit_message>
Deploying to gh-pages from @ tamanh-oxford/capacity-development@2ec6c12c7230a70b48a6138e71768d7efb7e5561 🚀
</commit_message>
<xml_diff>
--- a/vi/data-frameworks/12-financing-data.pptx
+++ b/vi/data-frameworks/12-financing-data.pptx
@@ -4125,14 +4125,14 @@
             <a:pPr lvl="0"/>
             <a:r>
               <a:rPr/>
-              <a:t>Quản lý quản trị dữ liệu: $120.000-$180.000</a:t>
+              <a:t>Quản lý quản trị dữ liệu: $120,000 - $180,000</a:t>
             </a:r>
           </a:p>
           <a:p>
             <a:pPr lvl="0"/>
             <a:r>
               <a:rPr/>
-              <a:t>Chuyên viên quản lý dữ liệu: $85.000-$130.000 cho mỗi nhân sự</a:t>
+              <a:t>Chuyên viên quản lý dữ liệu: $85,000-$130,000 cho mỗi nhân sự</a:t>
             </a:r>
           </a:p>
           <a:p>
@@ -4522,7 +4522,7 @@
             <a:pPr lvl="0"/>
             <a:r>
               <a:rPr/>
-              <a:t>Các tổ chức có thể giảm tổng chi phí sở hữu (TCO) từ 30-45% trong vòng năm năm thông qua các giải pháp quản trị dựa trên đám mây.</a:t>
+              <a:t>Các tổ chức có thể giảm tổng chi phí sở hữu (CTO) từ 30-45% trong vòng năm năm thông qua các giải pháp quản trị dựa trên đám mây.</a:t>
             </a:r>
           </a:p>
         </p:txBody>

</xml_diff>